<commit_message>
Slide 7: state explicitly that 3B was designed after and because of the 3A results, pre-specified before its own recruitment
Co-Authored-By: Claude Fable 5 <noreply@anthropic.com>
Claude-Session: https://claude.ai/code/session_01KoT3i8geZspYBMMKVYJUTG
</commit_message>
<xml_diff>
--- a/docs/presentations/EngD_Update_8_Final_Review_September2026_revD.pptx
+++ b/docs/presentations/EngD_Update_8_Final_Review_September2026_revD.pptx
@@ -1266,8 +1266,7 @@
           <a:lstStyle/>
           <a:p>
             <a:r>
-              <a:rPr lang="en-US" dirty="0"/>
-              <a:t>75 sec. Deliver three beats: (1) collection COMMENCED IN AUGUST 2026; (2) the INTENDED COMPARISON — adaptive calibration + trajectory + coaching vs static difficulty, randomised in-build, estimating the combined effect; (3) STATUS — deployed procedures and returns are being checked against the protocol before classification and analysis. If asked about contingencies: they arise only if verification does not support the 3B classification and rest with my supervisor; a single-arm route would provide no between-group estimate, so objective and claims would be revised accordingly.</a:t>
+              <a:t>75 sec. Deliver three beats: (1) collection COMMENCED IN AUGUST 2026; (2) the INTENDED COMPARISON — adaptive calibration + trajectory + coaching vs static difficulty, randomised in-build, estimating the combined effect; (3) STATUS — deployed procedures and returns are being checked against the protocol before classification and analysis. If asked about contingencies: they arise only if verification does not support the 3B classification and rest with my supervisor; a single-arm route would provide no between-group estimate, so objective and claims would be revised accordingly. If challenged on sequence: Stage 3B is retrospectively motivated but prospectively specified - designed after the 3A results licensed the question, with its analysis plan fixed before any 3B recruitment. That is the intended logic of a staged programme.</a:t>
             </a:r>
           </a:p>
         </p:txBody>
@@ -9993,7 +9992,7 @@
                 <a:ea typeface="Calibri" pitchFamily="34" charset="-122"/>
                 <a:cs typeface="Calibri" pitchFamily="34" charset="-120"/>
               </a:rPr>
-              <a:t>Why 3B — what 3A could not answer   </a:t>
+              <a:t>Why 3B — designed after, and because of, the 3A results   </a:t>
             </a:r>
             <a:r>
               <a:rPr lang="en-US" sz="1400" dirty="0">
@@ -10022,7 +10021,16 @@
                 </a:solidFill>
                 <a:latin typeface="Calibri"/>
               </a:rPr>
-              <a:t>Stage 3A removed the FRA verdict and engagement held — but it cannot serve users who need the measurement, did not evaluate the Chapter-7 adaptive-learning framework, and cannot support causal attribution. Stage 3B fields the designed response — AI-featured gamification where the system adapts to the player — with measurement visible; the reported 3A record is unchanged.</a:t>
+              <a:t/>
+            </a:r>
+            <a:r>
+              <a:rPr b="0" sz="1150">
+                <a:solidFill>
+                  <a:srgbClr val="222222"/>
+                </a:solidFill>
+                <a:latin typeface="Calibri"/>
+              </a:rPr>
+              <a:t>Stage 3A showed engagement holds when the FRA verdict is removed — but it cannot serve users who need the measurement and did not test the Chapter-7 framework. Stage 3B was therefore designed in August 2026, once the 3A results made that gap precise, and pre-specified before its own recruitment: AI-featured gamification where the system adapts to the player, with measurement visible. The reported 3A record is unchanged.</a:t>
             </a:r>
             <a:endParaRPr lang="en-US" sz="1600" dirty="0"/>
           </a:p>

</xml_diff>

<commit_message>
Split the Stage-3B slide into two infographic slides: design-space logic and deployment pipeline
Co-Authored-By: Claude Fable 5 <noreply@anthropic.com>
Claude-Session: https://claude.ai/code/session_01KoT3i8geZspYBMMKVYJUTG
</commit_message>
<xml_diff>
--- a/docs/presentations/EngD_Update_8_Final_Review_September2026_revD.pptx
+++ b/docs/presentations/EngD_Update_8_Final_Review_September2026_revD.pptx
@@ -16,6 +16,7 @@
     <p:sldId id="260" r:id="rId6"/>
     <p:sldId id="261" r:id="rId7"/>
     <p:sldId id="262" r:id="rId8"/>
+    <p:sldId id="268" r:id="rId19"/>
     <p:sldId id="267" r:id="rId18"/>
     <p:sldId id="263" r:id="rId9"/>
     <p:sldId id="264" r:id="rId10"/>
@@ -786,6 +787,76 @@
 </p:notes>
 </file>
 
+<file path=ppt/notesSlides/notesSlide13.xml><?xml version="1.0" encoding="utf-8"?>
+<p:notes xmlns:a="http://schemas.openxmlformats.org/drawingml/2006/main" xmlns:p="http://schemas.openxmlformats.org/presentationml/2006/main" xmlns:r="http://schemas.openxmlformats.org/officeDocument/2006/relationships">
+  <p:cSld>
+    <p:spTree>
+      <p:nvGrpSpPr>
+        <p:cNvPr id="1" name=""/>
+        <p:cNvGrpSpPr/>
+        <p:nvPr/>
+      </p:nvGrpSpPr>
+      <p:grpSpPr>
+        <a:xfrm>
+          <a:off x="0" y="0"/>
+          <a:ext cx="0" cy="0"/>
+          <a:chOff x="0" y="0"/>
+          <a:chExt cx="0" cy="0"/>
+        </a:xfrm>
+      </p:grpSpPr>
+      <p:sp>
+        <p:nvSpPr>
+          <p:cNvPr id="2" name="Slide Image Placeholder 1"/>
+          <p:cNvSpPr>
+            <a:spLocks noGrp="1"/>
+          </p:cNvSpPr>
+          <p:nvPr>
+            <p:ph type="sldImg" idx="2"/>
+          </p:nvPr>
+        </p:nvSpPr>
+        <p:spPr/>
+      </p:sp>
+      <p:sp>
+        <p:nvSpPr>
+          <p:cNvPr id="3" name="Notes Placeholder 2"/>
+          <p:cNvSpPr>
+            <a:spLocks noGrp="1"/>
+          </p:cNvSpPr>
+          <p:nvPr>
+            <p:ph type="body" idx="3" sz="quarter"/>
+          </p:nvPr>
+        </p:nvSpPr>
+        <p:spPr/>
+        <p:txBody>
+          <a:bodyPr/>
+          <a:lstStyle/>
+          <a:p>
+            <a:r>
+              <a:t>45 sec. Five steps, one gate: the plan was fixed before distribution; play is consented in-build and silently randomised; returns come back through each device's archive; verification and classification come before any analysis. Status: window open, close date to be set with my supervisor, everything inside the ethics period to 30 October. Deployment records are archived: distribution messages, the deployed device files, and the first verified return with a complete dated chain.</a:t>
+            </a:r>
+          </a:p>
+        </p:txBody>
+      </p:sp>
+      <p:sp>
+        <p:nvSpPr>
+          <p:cNvPr id="4" name="Slide Number Placeholder 3"/>
+          <p:cNvSpPr>
+            <a:spLocks noGrp="1"/>
+          </p:cNvSpPr>
+          <p:nvPr>
+            <p:ph type="sldNum" idx="5" sz="quarter"/>
+          </p:nvPr>
+        </p:nvSpPr>
+        <p:spPr/>
+      </p:sp>
+    </p:spTree>
+  </p:cSld>
+  <p:clrMapOvr>
+    <a:masterClrMapping/>
+  </p:clrMapOvr>
+</p:notes>
+</file>
+
 <file path=ppt/notesSlides/notesSlide2.xml><?xml version="1.0" encoding="utf-8"?>
 <p:notes xmlns:a="http://schemas.openxmlformats.org/drawingml/2006/main" xmlns:r="http://schemas.openxmlformats.org/officeDocument/2006/relationships" xmlns:p="http://schemas.openxmlformats.org/presentationml/2006/main">
   <p:cSld>
@@ -1266,7 +1337,7 @@
           <a:lstStyle/>
           <a:p>
             <a:r>
-              <a:t>75 sec. Deliver three beats: (1) collection COMMENCED IN AUGUST 2026; (2) the INTENDED COMPARISON — adaptive calibration + trajectory + coaching vs static difficulty, randomised in-build, estimating the combined effect; (3) STATUS — deployed procedures and returns are being checked against the protocol before classification and analysis. If asked about contingencies: they arise only if verification does not support the 3B classification and rest with my supervisor; a single-arm route would provide no between-group estimate, so objective and claims would be revised accordingly. If challenged on sequence: Stage 3B is retrospectively motivated but prospectively specified - designed after the 3A results licensed the question, with its analysis plan fixed before any 3B recruitment. That is the intended logic of a staged programme.</a:t>
+              <a:t>60 sec. Walk the diagram left to right: coupled deployment - use collapsed; decoupled deployment - participation held; the 3A result licensed the question 3B answers - can measurement stay visible if the system adapts to the player? Designed August 2026, after the 3A results; pre-specified before its own recruitment (repository-dated 8-9 Aug). H-3B is exploratory: combined effect only, no component isolation. Per-protocol participant experience if asked: bilingual v3.0 game, in-build consent, silent random assignment (adaptive calibration + trajectory + coaching vs static), end-screen questionnaire, one-file export, target N &gt;= 40. If challenged on sequence: retrospectively motivated, prospectively specified - the intended logic of a staged programme.</a:t>
             </a:r>
           </a:p>
         </p:txBody>
@@ -2514,6 +2585,493 @@
 </file>
 
 <file path=ppt/slides/slide10.xml><?xml version="1.0" encoding="utf-8"?>
+<p:sld xmlns:a="http://schemas.openxmlformats.org/drawingml/2006/main" xmlns:p="http://schemas.openxmlformats.org/presentationml/2006/main" xmlns:r="http://schemas.openxmlformats.org/officeDocument/2006/relationships">
+  <p:cSld>
+    <p:spTree>
+      <p:nvGrpSpPr>
+        <p:cNvPr id="1" name=""/>
+        <p:cNvGrpSpPr/>
+        <p:nvPr/>
+      </p:nvGrpSpPr>
+      <p:grpSpPr/>
+      <p:sp>
+        <p:nvSpPr>
+          <p:cNvPr id="2" name="TextBox 1"/>
+          <p:cNvSpPr txBox="1"/>
+          <p:nvPr/>
+        </p:nvSpPr>
+        <p:spPr>
+          <a:xfrm>
+            <a:off x="502920" y="274320"/>
+            <a:ext cx="11155680" cy="640080"/>
+          </a:xfrm>
+          <a:prstGeom prst="rect">
+            <a:avLst/>
+          </a:prstGeom>
+          <a:noFill/>
+        </p:spPr>
+        <p:txBody>
+          <a:bodyPr wrap="square" lIns="0" rIns="0" tIns="0" bIns="0">
+            <a:spAutoFit/>
+          </a:bodyPr>
+          <a:lstStyle/>
+          <a:p>
+            <a:r>
+              <a:rPr sz="3100" b="1" i="0">
+                <a:solidFill>
+                  <a:srgbClr val="1E2761"/>
+                </a:solidFill>
+                <a:latin typeface="Cambria"/>
+              </a:rPr>
+              <a:t>Stage 3B — first evidence from the field</a:t>
+            </a:r>
+          </a:p>
+        </p:txBody>
+      </p:sp>
+      <p:sp>
+        <p:nvSpPr>
+          <p:cNvPr id="3" name="TextBox 2"/>
+          <p:cNvSpPr txBox="1"/>
+          <p:nvPr/>
+        </p:nvSpPr>
+        <p:spPr>
+          <a:xfrm>
+            <a:off x="502920" y="905256"/>
+            <a:ext cx="11155680" cy="329184"/>
+          </a:xfrm>
+          <a:prstGeom prst="rect">
+            <a:avLst/>
+          </a:prstGeom>
+          <a:noFill/>
+        </p:spPr>
+        <p:txBody>
+          <a:bodyPr wrap="square" lIns="0" rIns="0" tIns="0" bIns="0">
+            <a:spAutoFit/>
+          </a:bodyPr>
+          <a:lstStyle/>
+          <a:p>
+            <a:r>
+              <a:rPr sz="1400" b="0" i="1">
+                <a:solidFill>
+                  <a:srgbClr val="5A6172"/>
+                </a:solidFill>
+                <a:latin typeface="Calibri"/>
+              </a:rPr>
+              <a:t>Real artifacts only; analysis awaits window close and classification</a:t>
+            </a:r>
+          </a:p>
+        </p:txBody>
+      </p:sp>
+      <p:pic>
+        <p:nvPicPr>
+          <p:cNvPr id="4" name="Picture 3" descr="1_consent.png"/>
+          <p:cNvPicPr>
+            <a:picLocks noChangeAspect="1"/>
+          </p:cNvPicPr>
+          <p:nvPr/>
+        </p:nvPicPr>
+        <p:blipFill>
+          <a:blip r:embed="rId2"/>
+          <a:stretch>
+            <a:fillRect/>
+          </a:stretch>
+        </p:blipFill>
+        <p:spPr>
+          <a:xfrm>
+            <a:off x="502920" y="1417320"/>
+            <a:ext cx="2697480" cy="1685925"/>
+          </a:xfrm>
+          <a:prstGeom prst="rect">
+            <a:avLst/>
+          </a:prstGeom>
+        </p:spPr>
+      </p:pic>
+      <p:sp>
+        <p:nvSpPr>
+          <p:cNvPr id="5" name="TextBox 4"/>
+          <p:cNvSpPr txBox="1"/>
+          <p:nvPr/>
+        </p:nvSpPr>
+        <p:spPr>
+          <a:xfrm>
+            <a:off x="502920" y="3200400"/>
+            <a:ext cx="2697480" cy="256032"/>
+          </a:xfrm>
+          <a:prstGeom prst="rect">
+            <a:avLst/>
+          </a:prstGeom>
+          <a:noFill/>
+        </p:spPr>
+        <p:txBody>
+          <a:bodyPr wrap="square" lIns="0" rIns="0" tIns="0" bIns="0">
+            <a:spAutoFit/>
+          </a:bodyPr>
+          <a:lstStyle/>
+          <a:p>
+            <a:pPr algn="ctr"/>
+            <a:r>
+              <a:rPr sz="1050" b="0" i="1">
+                <a:solidFill>
+                  <a:srgbClr val="5A6172"/>
+                </a:solidFill>
+                <a:latin typeface="Calibri"/>
+              </a:rPr>
+              <a:t>In-build consent</a:t>
+            </a:r>
+          </a:p>
+        </p:txBody>
+      </p:sp>
+      <p:pic>
+        <p:nvPicPr>
+          <p:cNvPr id="6" name="Picture 5" descr="2_gameplay.png"/>
+          <p:cNvPicPr>
+            <a:picLocks noChangeAspect="1"/>
+          </p:cNvPicPr>
+          <p:nvPr/>
+        </p:nvPicPr>
+        <p:blipFill>
+          <a:blip r:embed="rId3"/>
+          <a:stretch>
+            <a:fillRect/>
+          </a:stretch>
+        </p:blipFill>
+        <p:spPr>
+          <a:xfrm>
+            <a:off x="3346704" y="1417320"/>
+            <a:ext cx="2697480" cy="1685925"/>
+          </a:xfrm>
+          <a:prstGeom prst="rect">
+            <a:avLst/>
+          </a:prstGeom>
+        </p:spPr>
+      </p:pic>
+      <p:sp>
+        <p:nvSpPr>
+          <p:cNvPr id="7" name="TextBox 6"/>
+          <p:cNvSpPr txBox="1"/>
+          <p:nvPr/>
+        </p:nvSpPr>
+        <p:spPr>
+          <a:xfrm>
+            <a:off x="3346704" y="3200400"/>
+            <a:ext cx="2697480" cy="256032"/>
+          </a:xfrm>
+          <a:prstGeom prst="rect">
+            <a:avLst/>
+          </a:prstGeom>
+          <a:noFill/>
+        </p:spPr>
+        <p:txBody>
+          <a:bodyPr wrap="square" lIns="0" rIns="0" tIns="0" bIns="0">
+            <a:spAutoFit/>
+          </a:bodyPr>
+          <a:lstStyle/>
+          <a:p>
+            <a:pPr algn="ctr"/>
+            <a:r>
+              <a:rPr sz="1050" b="0" i="1">
+                <a:solidFill>
+                  <a:srgbClr val="5A6172"/>
+                </a:solidFill>
+                <a:latin typeface="Calibri"/>
+              </a:rPr>
+              <a:t>30-second run</a:t>
+            </a:r>
+          </a:p>
+        </p:txBody>
+      </p:sp>
+      <p:pic>
+        <p:nvPicPr>
+          <p:cNvPr id="8" name="Picture 7" descr="3_questionnaire.png"/>
+          <p:cNvPicPr>
+            <a:picLocks noChangeAspect="1"/>
+          </p:cNvPicPr>
+          <p:nvPr/>
+        </p:nvPicPr>
+        <p:blipFill>
+          <a:blip r:embed="rId4"/>
+          <a:stretch>
+            <a:fillRect/>
+          </a:stretch>
+        </p:blipFill>
+        <p:spPr>
+          <a:xfrm>
+            <a:off x="6190488" y="1417320"/>
+            <a:ext cx="2697480" cy="1685925"/>
+          </a:xfrm>
+          <a:prstGeom prst="rect">
+            <a:avLst/>
+          </a:prstGeom>
+        </p:spPr>
+      </p:pic>
+      <p:sp>
+        <p:nvSpPr>
+          <p:cNvPr id="9" name="TextBox 8"/>
+          <p:cNvSpPr txBox="1"/>
+          <p:nvPr/>
+        </p:nvSpPr>
+        <p:spPr>
+          <a:xfrm>
+            <a:off x="6190488" y="3200400"/>
+            <a:ext cx="2697480" cy="256032"/>
+          </a:xfrm>
+          <a:prstGeom prst="rect">
+            <a:avLst/>
+          </a:prstGeom>
+          <a:noFill/>
+        </p:spPr>
+        <p:txBody>
+          <a:bodyPr wrap="square" lIns="0" rIns="0" tIns="0" bIns="0">
+            <a:spAutoFit/>
+          </a:bodyPr>
+          <a:lstStyle/>
+          <a:p>
+            <a:pPr algn="ctr"/>
+            <a:r>
+              <a:rPr sz="1050" b="0" i="1">
+                <a:solidFill>
+                  <a:srgbClr val="5A6172"/>
+                </a:solidFill>
+                <a:latin typeface="Calibri"/>
+              </a:rPr>
+              <a:t>End-screen questionnaire</a:t>
+            </a:r>
+          </a:p>
+        </p:txBody>
+      </p:sp>
+      <p:pic>
+        <p:nvPicPr>
+          <p:cNvPr id="10" name="Picture 9" descr="4_return_screen.png"/>
+          <p:cNvPicPr>
+            <a:picLocks noChangeAspect="1"/>
+          </p:cNvPicPr>
+          <p:nvPr/>
+        </p:nvPicPr>
+        <p:blipFill>
+          <a:blip r:embed="rId5"/>
+          <a:stretch>
+            <a:fillRect/>
+          </a:stretch>
+        </p:blipFill>
+        <p:spPr>
+          <a:xfrm>
+            <a:off x="9034272" y="1417320"/>
+            <a:ext cx="2697480" cy="1685925"/>
+          </a:xfrm>
+          <a:prstGeom prst="rect">
+            <a:avLst/>
+          </a:prstGeom>
+        </p:spPr>
+      </p:pic>
+      <p:sp>
+        <p:nvSpPr>
+          <p:cNvPr id="11" name="TextBox 10"/>
+          <p:cNvSpPr txBox="1"/>
+          <p:nvPr/>
+        </p:nvSpPr>
+        <p:spPr>
+          <a:xfrm>
+            <a:off x="9034272" y="3200400"/>
+            <a:ext cx="2697480" cy="256032"/>
+          </a:xfrm>
+          <a:prstGeom prst="rect">
+            <a:avLst/>
+          </a:prstGeom>
+          <a:noFill/>
+        </p:spPr>
+        <p:txBody>
+          <a:bodyPr wrap="square" lIns="0" rIns="0" tIns="0" bIns="0">
+            <a:spAutoFit/>
+          </a:bodyPr>
+          <a:lstStyle/>
+          <a:p>
+            <a:pPr algn="ctr"/>
+            <a:r>
+              <a:rPr sz="1050" b="0" i="1">
+                <a:solidFill>
+                  <a:srgbClr val="5A6172"/>
+                </a:solidFill>
+                <a:latin typeface="Calibri"/>
+              </a:rPr>
+              <a:t>Results return</a:t>
+            </a:r>
+          </a:p>
+        </p:txBody>
+      </p:sp>
+      <p:sp>
+        <p:nvSpPr>
+          <p:cNvPr id="12" name="Rounded Rectangle 11"/>
+          <p:cNvSpPr/>
+          <p:nvPr/>
+        </p:nvSpPr>
+        <p:spPr>
+          <a:xfrm>
+            <a:off x="502920" y="3611880"/>
+            <a:ext cx="11192256" cy="1600200"/>
+          </a:xfrm>
+          <a:prstGeom prst="roundRect">
+            <a:avLst/>
+          </a:prstGeom>
+          <a:solidFill>
+            <a:srgbClr val="EAF3EE"/>
+          </a:solidFill>
+          <a:ln>
+            <a:noFill/>
+          </a:ln>
+        </p:spPr>
+        <p:style>
+          <a:lnRef idx="1">
+            <a:schemeClr val="accent1"/>
+          </a:lnRef>
+          <a:fillRef idx="3">
+            <a:schemeClr val="accent1"/>
+          </a:fillRef>
+          <a:effectRef idx="2">
+            <a:schemeClr val="accent1"/>
+          </a:effectRef>
+          <a:fontRef idx="minor">
+            <a:schemeClr val="lt1"/>
+          </a:fontRef>
+        </p:style>
+        <p:txBody>
+          <a:bodyPr rtlCol="0" anchor="ctr" wrap="square" lIns="274320" rIns="274320" tIns="109728"/>
+          <a:lstStyle/>
+          <a:p>
+            <a:pPr algn="ctr"/>
+            <a:r>
+              <a:rPr sz="1400" b="1">
+                <a:solidFill>
+                  <a:srgbClr val="2C6E49"/>
+                </a:solidFill>
+                <a:latin typeface="Calibri"/>
+              </a:rPr>
+              <a:t>First verified return — complete chain of custody</a:t>
+            </a:r>
+          </a:p>
+          <a:p>
+            <a:r>
+              <a:rPr sz="1200">
+                <a:solidFill>
+                  <a:srgbClr val="222222"/>
+                </a:solidFill>
+                <a:latin typeface="Calibri"/>
+              </a:rPr>
+              <a:t>Game file (device copy DEV2) sent to a distributor by WeChat 10 Aug → participant consented and played 15 Aug (in-build timestamp) → return e-mailed to the researcher the same day → archived as received. Return fields match the deployed build generation exactly (arm, failure-mode, scoring). Enrolment 45–64/F; one session; questionnaire complete.</a:t>
+            </a:r>
+          </a:p>
+        </p:txBody>
+      </p:sp>
+      <p:sp>
+        <p:nvSpPr>
+          <p:cNvPr id="13" name="TextBox 12"/>
+          <p:cNvSpPr txBox="1"/>
+          <p:nvPr/>
+        </p:nvSpPr>
+        <p:spPr>
+          <a:xfrm>
+            <a:off x="502920" y="5394960"/>
+            <a:ext cx="11192256" cy="868680"/>
+          </a:xfrm>
+          <a:prstGeom prst="rect">
+            <a:avLst/>
+          </a:prstGeom>
+          <a:noFill/>
+        </p:spPr>
+        <p:txBody>
+          <a:bodyPr wrap="square" lIns="0" rIns="0" tIns="0" bIns="0">
+            <a:spAutoFit/>
+          </a:bodyPr>
+          <a:lstStyle/>
+          <a:p>
+            <a:r>
+              <a:rPr sz="1250" b="0" i="0">
+                <a:solidFill>
+                  <a:srgbClr val="222222"/>
+                </a:solidFill>
+                <a:latin typeface="Calibri"/>
+              </a:rPr>
+              <a:t>Deployment status (author records): ~20 distributors reached ~100 recipients; distribution from 9–12 Aug onward, after the analysis plan was fixed in the repository (9 Aug). Returns are being collected via each device's built-in archive; the count will be reported at window close.</a:t>
+            </a:r>
+          </a:p>
+        </p:txBody>
+      </p:sp>
+      <p:sp>
+        <p:nvSpPr>
+          <p:cNvPr id="14" name="TextBox 13"/>
+          <p:cNvSpPr txBox="1"/>
+          <p:nvPr/>
+        </p:nvSpPr>
+        <p:spPr>
+          <a:xfrm>
+            <a:off x="502920" y="6473952"/>
+            <a:ext cx="8229600" cy="274320"/>
+          </a:xfrm>
+          <a:prstGeom prst="rect">
+            <a:avLst/>
+          </a:prstGeom>
+          <a:noFill/>
+        </p:spPr>
+        <p:txBody>
+          <a:bodyPr wrap="square" lIns="0" rIns="0" tIns="0" bIns="0">
+            <a:spAutoFit/>
+          </a:bodyPr>
+          <a:lstStyle/>
+          <a:p>
+            <a:r>
+              <a:rPr sz="1000" b="0" i="0">
+                <a:solidFill>
+                  <a:srgbClr val="5A6172"/>
+                </a:solidFill>
+                <a:latin typeface="Calibri"/>
+              </a:rPr>
+              <a:t>Sidney K.T. Tam  |  EngD Final Review (Update 8, rev. D)  |  PolyU ISE  |  September 2026</a:t>
+            </a:r>
+          </a:p>
+        </p:txBody>
+      </p:sp>
+      <p:sp>
+        <p:nvSpPr>
+          <p:cNvPr id="15" name="TextBox 14"/>
+          <p:cNvSpPr txBox="1"/>
+          <p:nvPr/>
+        </p:nvSpPr>
+        <p:spPr>
+          <a:xfrm>
+            <a:off x="11384280" y="6473952"/>
+            <a:ext cx="365760" cy="274320"/>
+          </a:xfrm>
+          <a:prstGeom prst="rect">
+            <a:avLst/>
+          </a:prstGeom>
+          <a:noFill/>
+        </p:spPr>
+        <p:txBody>
+          <a:bodyPr wrap="square" lIns="0" rIns="0" tIns="0" bIns="0">
+            <a:spAutoFit/>
+          </a:bodyPr>
+          <a:lstStyle/>
+          <a:p>
+            <a:r>
+              <a:rPr sz="1000" b="0" i="0">
+                <a:solidFill>
+                  <a:srgbClr val="5A6172"/>
+                </a:solidFill>
+                <a:latin typeface="Calibri"/>
+              </a:rPr>
+              <a:t>9</a:t>
+            </a:r>
+          </a:p>
+        </p:txBody>
+      </p:sp>
+    </p:spTree>
+  </p:cSld>
+  <p:clrMapOvr>
+    <a:masterClrMapping/>
+  </p:clrMapOvr>
+</p:sld>
+</file>
+
+<file path=ppt/slides/slide11.xml><?xml version="1.0" encoding="utf-8"?>
 <p:sld xmlns:a="http://schemas.openxmlformats.org/drawingml/2006/main" xmlns:r="http://schemas.openxmlformats.org/officeDocument/2006/relationships" xmlns:p="http://schemas.openxmlformats.org/presentationml/2006/main">
   <p:cSld name="Slide 8">
     <p:spTree>
@@ -3342,7 +3900,7 @@
 </p:sld>
 </file>
 
-<file path=ppt/slides/slide11.xml><?xml version="1.0" encoding="utf-8"?>
+<file path=ppt/slides/slide12.xml><?xml version="1.0" encoding="utf-8"?>
 <p:sld xmlns:a="http://schemas.openxmlformats.org/drawingml/2006/main" xmlns:r="http://schemas.openxmlformats.org/officeDocument/2006/relationships" xmlns:p="http://schemas.openxmlformats.org/presentationml/2006/main">
   <p:cSld name="Slide 9">
     <p:spTree>
@@ -4335,7 +4893,7 @@
 </p:sld>
 </file>
 
-<file path=ppt/slides/slide12.xml><?xml version="1.0" encoding="utf-8"?>
+<file path=ppt/slides/slide13.xml><?xml version="1.0" encoding="utf-8"?>
 <p:sld xmlns:a="http://schemas.openxmlformats.org/drawingml/2006/main" xmlns:r="http://schemas.openxmlformats.org/officeDocument/2006/relationships" xmlns:p="http://schemas.openxmlformats.org/presentationml/2006/main">
   <p:cSld name="Slide 10">
     <p:spTree>
@@ -9798,46 +10356,41 @@
       </p:grpSpPr>
       <p:sp>
         <p:nvSpPr>
-          <p:cNvPr id="2" name="Text 0"/>
+          <p:cNvPr id="2" name="TextBox 1"/>
           <p:cNvSpPr txBox="1"/>
           <p:nvPr/>
         </p:nvSpPr>
         <p:spPr>
           <a:xfrm>
             <a:off x="502920" y="274320"/>
-            <a:ext cx="11155680" cy="658368"/>
-          </a:xfrm>
-          <a:prstGeom prst="rect">
-            <a:avLst/>
-          </a:prstGeom>
-          <a:noFill/>
-          <a:ln/>
-        </p:spPr>
-        <p:txBody>
-          <a:bodyPr wrap="square" lIns="0" tIns="0" rIns="0" bIns="0" rtlCol="0" anchor="ctr"/>
-          <a:lstStyle/>
-          <a:p>
-            <a:pPr marL="0" indent="0">
-              <a:buNone/>
-            </a:pPr>
-            <a:r>
-              <a:rPr lang="en-US" sz="3100" b="1" dirty="0">
+            <a:ext cx="11155680" cy="640080"/>
+          </a:xfrm>
+          <a:prstGeom prst="rect">
+            <a:avLst/>
+          </a:prstGeom>
+          <a:noFill/>
+        </p:spPr>
+        <p:txBody>
+          <a:bodyPr wrap="square" lIns="0" rIns="0" tIns="0" bIns="0">
+            <a:spAutoFit/>
+          </a:bodyPr>
+          <a:lstStyle/>
+          <a:p>
+            <a:r>
+              <a:rPr sz="3100" b="1" i="0">
                 <a:solidFill>
                   <a:srgbClr val="1E2761"/>
                 </a:solidFill>
-                <a:latin typeface="Cambria" pitchFamily="34" charset="0"/>
-                <a:ea typeface="Cambria" pitchFamily="34" charset="-122"/>
-                <a:cs typeface="Cambria" pitchFamily="34" charset="-120"/>
-              </a:rPr>
-              <a:t>Stage 3B: deployment under verification</a:t>
-            </a:r>
-            <a:endParaRPr lang="en-US" sz="3100" dirty="0"/>
-          </a:p>
-        </p:txBody>
-      </p:sp>
-      <p:sp>
-        <p:nvSpPr>
-          <p:cNvPr id="3" name="Text 1"/>
+                <a:latin typeface="Cambria"/>
+              </a:rPr>
+              <a:t>Why Stage 3B — the middle ground</a:t>
+            </a:r>
+          </a:p>
+        </p:txBody>
+      </p:sp>
+      <p:sp>
+        <p:nvSpPr>
+          <p:cNvPr id="3" name="TextBox 2"/>
           <p:cNvSpPr txBox="1"/>
           <p:nvPr/>
         </p:nvSpPr>
@@ -9850,516 +10403,52 @@
             <a:avLst/>
           </a:prstGeom>
           <a:noFill/>
-          <a:ln/>
-        </p:spPr>
-        <p:txBody>
-          <a:bodyPr wrap="square" lIns="0" tIns="0" rIns="0" bIns="0" rtlCol="0" anchor="ctr"/>
-          <a:lstStyle/>
-          <a:p>
-            <a:pPr marL="0" indent="0">
-              <a:buNone/>
-            </a:pPr>
-            <a:r>
-              <a:rPr lang="en-US" i="1" dirty="0">
+        </p:spPr>
+        <p:txBody>
+          <a:bodyPr wrap="square" lIns="0" rIns="0" tIns="0" bIns="0">
+            <a:spAutoFit/>
+          </a:bodyPr>
+          <a:lstStyle/>
+          <a:p>
+            <a:r>
+              <a:rPr sz="1400" b="0" i="1">
                 <a:solidFill>
                   <a:srgbClr val="5A6172"/>
                 </a:solidFill>
-                <a:latin typeface="Calibri" pitchFamily="34" charset="0"/>
-                <a:ea typeface="Calibri" pitchFamily="34" charset="-122"/>
-                <a:cs typeface="Calibri" pitchFamily="34" charset="-120"/>
-              </a:rPr>
-              <a:t>Why Stage 3 has two parts, what participants experience, and where the data stand</a:t>
-            </a:r>
-            <a:endParaRPr lang="en-US" dirty="0"/>
-          </a:p>
-        </p:txBody>
-      </p:sp>
-      <p:sp>
-        <p:nvSpPr>
-          <p:cNvPr id="4" name="Shape 2"/>
-          <p:cNvSpPr/>
-          <p:nvPr/>
-        </p:nvSpPr>
-        <p:spPr>
-          <a:xfrm>
-            <a:off x="502920" y="1426464"/>
-            <a:ext cx="6949440" cy="1335024"/>
-          </a:xfrm>
-          <a:prstGeom prst="roundRect">
-            <a:avLst>
-              <a:gd name="adj" fmla="val 5479"/>
-            </a:avLst>
-          </a:prstGeom>
-          <a:solidFill>
-            <a:srgbClr val="1E2761"/>
-          </a:solidFill>
-          <a:ln/>
-        </p:spPr>
-        <p:txBody>
-          <a:bodyPr/>
-          <a:lstStyle/>
-          <a:p>
-            <a:endParaRPr lang="en-US"/>
-          </a:p>
-        </p:txBody>
-      </p:sp>
-      <p:sp>
-        <p:nvSpPr>
-          <p:cNvPr id="5" name="Text 3"/>
-          <p:cNvSpPr txBox="1"/>
-          <p:nvPr/>
-        </p:nvSpPr>
-        <p:spPr>
-          <a:xfrm>
-            <a:off x="822960" y="1517904"/>
-            <a:ext cx="6355080" cy="1152144"/>
-          </a:xfrm>
-          <a:prstGeom prst="rect">
-            <a:avLst/>
-          </a:prstGeom>
-          <a:noFill/>
-          <a:ln/>
-        </p:spPr>
-        <p:txBody>
-          <a:bodyPr wrap="square" lIns="0" tIns="0" rIns="0" bIns="0" rtlCol="0" anchor="ctr"/>
-          <a:lstStyle/>
-          <a:p>
-            <a:pPr marL="0" indent="0">
-              <a:lnSpc>
-                <a:spcPct val="108000"/>
-              </a:lnSpc>
-              <a:buNone/>
-            </a:pPr>
-            <a:r>
-              <a:rPr lang="en-US" sz="1600" b="1" dirty="0">
-                <a:solidFill>
-                  <a:srgbClr val="CADCFC"/>
-                </a:solidFill>
-                <a:latin typeface="Calibri" pitchFamily="34" charset="0"/>
-                <a:ea typeface="Calibri" pitchFamily="34" charset="-122"/>
-                <a:cs typeface="Calibri" pitchFamily="34" charset="-120"/>
-              </a:rPr>
-              <a:t>H-3B (exploratory):  </a:t>
-            </a:r>
-            <a:r>
-              <a:rPr lang="en-US" sz="1600" dirty="0">
-                <a:solidFill>
-                  <a:srgbClr val="FFFFFF"/>
-                </a:solidFill>
-                <a:latin typeface="Calibri" pitchFamily="34" charset="0"/>
-                <a:ea typeface="Calibri" pitchFamily="34" charset="-122"/>
-                <a:cs typeface="Calibri" pitchFamily="34" charset="-120"/>
-              </a:rPr>
-              <a:t>the combined intervention — adaptive calibration + trajectory display + coaching — sustains engagement even when measurement is visible.</a:t>
-            </a:r>
-            <a:endParaRPr lang="en-US" sz="1600" dirty="0"/>
-          </a:p>
-        </p:txBody>
-      </p:sp>
-      <p:sp>
-        <p:nvSpPr>
-          <p:cNvPr id="6" name="Text 4"/>
-          <p:cNvSpPr txBox="1"/>
-          <p:nvPr/>
-        </p:nvSpPr>
-        <p:spPr>
-          <a:xfrm>
-            <a:off x="502920" y="2884932"/>
-            <a:ext cx="6949440" cy="859536"/>
-          </a:xfrm>
-          <a:prstGeom prst="rect">
-            <a:avLst/>
-          </a:prstGeom>
-          <a:noFill/>
-          <a:ln/>
-        </p:spPr>
-        <p:txBody>
-          <a:bodyPr wrap="square" lIns="0" tIns="0" rIns="0" bIns="0" rtlCol="0" anchor="ctr"/>
-          <a:lstStyle/>
-          <a:p>
-            <a:pPr marL="0" indent="0">
-              <a:lnSpc>
-                <a:spcPct val="104000"/>
-              </a:lnSpc>
-              <a:buNone/>
-            </a:pPr>
-            <a:r>
-              <a:rPr lang="en-US" sz="1150" b="1" dirty="0">
-                <a:solidFill>
-                  <a:srgbClr val="1E2761"/>
-                </a:solidFill>
-                <a:latin typeface="Calibri" pitchFamily="34" charset="0"/>
-                <a:ea typeface="Calibri" pitchFamily="34" charset="-122"/>
-                <a:cs typeface="Calibri" pitchFamily="34" charset="-120"/>
-              </a:rPr>
-              <a:t>Why 3B — designed after, and because of, the 3A results   </a:t>
-            </a:r>
-            <a:r>
-              <a:rPr lang="en-US" sz="1400" dirty="0">
-                <a:solidFill>
-                  <a:srgbClr val="222222"/>
-                </a:solidFill>
-                <a:latin typeface="Calibri" pitchFamily="34" charset="0"/>
-                <a:ea typeface="Calibri" pitchFamily="34" charset="-122"/>
-                <a:cs typeface="Calibri" pitchFamily="34" charset="-120"/>
-              </a:rPr>
-              <a:t/>
-            </a:r>
-            <a:r>
-              <a:rPr b="0" sz="1150">
-                <a:solidFill>
-                  <a:srgbClr val="222222"/>
-                </a:solidFill>
                 <a:latin typeface="Calibri"/>
               </a:rPr>
-              <a:t/>
-            </a:r>
-            <a:r>
-              <a:rPr b="0" sz="1150">
-                <a:solidFill>
-                  <a:srgbClr val="222222"/>
-                </a:solidFill>
-                <a:latin typeface="Calibri"/>
-              </a:rPr>
-              <a:t/>
-            </a:r>
-            <a:r>
-              <a:rPr b="0" sz="1150">
-                <a:solidFill>
-                  <a:srgbClr val="222222"/>
-                </a:solidFill>
-                <a:latin typeface="Calibri"/>
-              </a:rPr>
-              <a:t>Stage 3A showed engagement holds when the FRA verdict is removed — but it cannot serve users who need the measurement and did not test the Chapter-7 framework. Stage 3B was therefore designed in August 2026, once the 3A results made that gap precise, and pre-specified before its own recruitment: AI-featured gamification where the system adapts to the player, with measurement visible. The reported 3A record is unchanged.</a:t>
-            </a:r>
-            <a:endParaRPr lang="en-US" sz="1600" dirty="0"/>
-          </a:p>
-        </p:txBody>
-      </p:sp>
-      <p:sp>
-        <p:nvSpPr>
-          <p:cNvPr id="7" name="Text 5"/>
-          <p:cNvSpPr txBox="1"/>
-          <p:nvPr/>
-        </p:nvSpPr>
-        <p:spPr>
-          <a:xfrm>
-            <a:off x="502920" y="3895344"/>
-            <a:ext cx="6949440" cy="859536"/>
-          </a:xfrm>
-          <a:prstGeom prst="rect">
-            <a:avLst/>
-          </a:prstGeom>
-          <a:noFill/>
-          <a:ln/>
-        </p:spPr>
-        <p:txBody>
-          <a:bodyPr wrap="square" lIns="0" tIns="0" rIns="0" bIns="0" rtlCol="0" anchor="ctr"/>
-          <a:lstStyle/>
-          <a:p>
-            <a:pPr marL="0" indent="0">
-              <a:lnSpc>
-                <a:spcPct val="104000"/>
-              </a:lnSpc>
-              <a:buNone/>
-            </a:pPr>
-            <a:r>
-              <a:rPr lang="en-US" sz="1600" b="1" dirty="0">
-                <a:solidFill>
-                  <a:srgbClr val="1E2761"/>
-                </a:solidFill>
-                <a:latin typeface="Calibri" pitchFamily="34" charset="0"/>
-                <a:ea typeface="Calibri" pitchFamily="34" charset="-122"/>
-                <a:cs typeface="Calibri" pitchFamily="34" charset="-120"/>
-              </a:rPr>
-              <a:t>Per-protocol participant experience   </a:t>
-            </a:r>
-            <a:r>
-              <a:rPr lang="en-US" sz="1400" dirty="0">
-                <a:solidFill>
-                  <a:srgbClr val="222222"/>
-                </a:solidFill>
-                <a:latin typeface="Calibri" pitchFamily="34" charset="0"/>
-                <a:ea typeface="Calibri" pitchFamily="34" charset="-122"/>
-                <a:cs typeface="Calibri" pitchFamily="34" charset="-120"/>
-              </a:rPr>
-              <a:t>The bilingual v3.0 game: in-build consent, silent random assignment (adaptive calibration + trajectory + coaching vs static difficulty), end-screen questionnaire, one-file export; target N ≥ 40. Estimates the combined effect — no component or framing isolation.</a:t>
-            </a:r>
-            <a:endParaRPr lang="en-US" sz="1600" dirty="0"/>
-          </a:p>
-        </p:txBody>
-      </p:sp>
-      <p:sp>
-        <p:nvSpPr>
-          <p:cNvPr id="8" name="Text 6"/>
-          <p:cNvSpPr txBox="1"/>
-          <p:nvPr/>
-        </p:nvSpPr>
-        <p:spPr>
-          <a:xfrm>
-            <a:off x="502920" y="4745736"/>
-            <a:ext cx="6949440" cy="859536"/>
-          </a:xfrm>
-          <a:prstGeom prst="rect">
-            <a:avLst/>
-          </a:prstGeom>
-          <a:noFill/>
-          <a:ln/>
-        </p:spPr>
-        <p:txBody>
-          <a:bodyPr wrap="square" lIns="0" tIns="0" rIns="0" bIns="0" rtlCol="0" anchor="ctr"/>
-          <a:lstStyle/>
-          <a:p>
-            <a:pPr marL="0" indent="0">
-              <a:lnSpc>
-                <a:spcPct val="104000"/>
-              </a:lnSpc>
-              <a:buNone/>
-            </a:pPr>
-            <a:r>
-              <a:rPr lang="en-US" sz="1600" b="1" dirty="0">
-                <a:solidFill>
-                  <a:srgbClr val="1E2761"/>
-                </a:solidFill>
-                <a:latin typeface="Calibri" pitchFamily="34" charset="0"/>
-                <a:ea typeface="Calibri" pitchFamily="34" charset="-122"/>
-                <a:cs typeface="Calibri" pitchFamily="34" charset="-120"/>
-              </a:rPr>
-              <a:t>Status   </a:t>
-            </a:r>
-            <a:r>
-              <a:rPr lang="en-US" sz="1400" dirty="0">
-                <a:solidFill>
-                  <a:srgbClr val="222222"/>
-                </a:solidFill>
-                <a:latin typeface="Calibri" pitchFamily="34" charset="0"/>
-                <a:ea typeface="Calibri" pitchFamily="34" charset="-122"/>
-                <a:cs typeface="Calibri" pitchFamily="34" charset="-120"/>
-              </a:rPr>
-              <a:t>Data collection commenced in August 2026. The deployed procedures and returned records are being checked against the Stage-3B protocol before final classification and analysis.</a:t>
-            </a:r>
-            <a:endParaRPr lang="en-US" sz="1600" dirty="0"/>
-          </a:p>
-        </p:txBody>
-      </p:sp>
-      <p:sp>
-        <p:nvSpPr>
-          <p:cNvPr id="9" name="Text 7"/>
-          <p:cNvSpPr txBox="1"/>
-          <p:nvPr/>
-        </p:nvSpPr>
-        <p:spPr>
-          <a:xfrm>
-            <a:off x="502920" y="5394960"/>
-            <a:ext cx="6949440" cy="859536"/>
-          </a:xfrm>
-          <a:prstGeom prst="rect">
-            <a:avLst/>
-          </a:prstGeom>
-          <a:noFill/>
-          <a:ln/>
-        </p:spPr>
-        <p:txBody>
-          <a:bodyPr wrap="square" lIns="0" tIns="0" rIns="0" bIns="0" rtlCol="0" anchor="ctr"/>
-          <a:lstStyle/>
-          <a:p>
-            <a:pPr marL="0" indent="0">
-              <a:lnSpc>
-                <a:spcPct val="104000"/>
-              </a:lnSpc>
-              <a:buNone/>
-            </a:pPr>
-            <a:r>
-              <a:rPr lang="en-US" sz="1600" b="1" dirty="0">
-                <a:solidFill>
-                  <a:srgbClr val="D97706"/>
-                </a:solidFill>
-                <a:latin typeface="Calibri" pitchFamily="34" charset="0"/>
-                <a:ea typeface="Calibri" pitchFamily="34" charset="-122"/>
-                <a:cs typeface="Calibri" pitchFamily="34" charset="-120"/>
-              </a:rPr>
-              <a:t>Next   </a:t>
-            </a:r>
-            <a:r>
-              <a:rPr lang="en-US" sz="1400" dirty="0">
-                <a:solidFill>
-                  <a:srgbClr val="222222"/>
-                </a:solidFill>
-                <a:latin typeface="Calibri" pitchFamily="34" charset="0"/>
-                <a:ea typeface="Calibri" pitchFamily="34" charset="-122"/>
-                <a:cs typeface="Calibri" pitchFamily="34" charset="-120"/>
-              </a:rPr>
-              <a:t>Verification of the deployed file and returns → classification → analysis under the pre-specified hierarchy (repository-dated 8–9 Aug 2026).</a:t>
-            </a:r>
-            <a:endParaRPr lang="en-US" sz="1600" dirty="0"/>
-          </a:p>
-        </p:txBody>
-      </p:sp>
-      <p:sp>
-        <p:nvSpPr>
-          <p:cNvPr id="10" name="Shape 8"/>
-          <p:cNvSpPr/>
-          <p:nvPr/>
-        </p:nvSpPr>
-        <p:spPr>
-          <a:xfrm>
-            <a:off x="7726679" y="1426464"/>
-            <a:ext cx="4170911" cy="4700016"/>
-          </a:xfrm>
-          <a:prstGeom prst="roundRect">
-            <a:avLst>
-              <a:gd name="adj" fmla="val 2069"/>
-            </a:avLst>
-          </a:prstGeom>
-          <a:solidFill>
-            <a:srgbClr val="EAF1FD"/>
-          </a:solidFill>
-          <a:ln/>
-        </p:spPr>
-        <p:txBody>
-          <a:bodyPr/>
-          <a:lstStyle/>
-          <a:p>
-            <a:endParaRPr lang="en-US"/>
-          </a:p>
-        </p:txBody>
-      </p:sp>
-      <p:sp>
-        <p:nvSpPr>
-          <p:cNvPr id="11" name="Text 9"/>
-          <p:cNvSpPr txBox="1"/>
-          <p:nvPr/>
-        </p:nvSpPr>
-        <p:spPr>
-          <a:xfrm>
-            <a:off x="8001000" y="1627632"/>
-            <a:ext cx="3474720" cy="365760"/>
-          </a:xfrm>
-          <a:prstGeom prst="rect">
-            <a:avLst/>
-          </a:prstGeom>
-          <a:noFill/>
-          <a:ln/>
-        </p:spPr>
-        <p:txBody>
-          <a:bodyPr wrap="square" lIns="0" tIns="0" rIns="0" bIns="0" rtlCol="0" anchor="ctr"/>
-          <a:lstStyle/>
-          <a:p>
-            <a:pPr marL="0" indent="0">
-              <a:buNone/>
-            </a:pPr>
-            <a:r>
-              <a:rPr lang="en-US" sz="1600" b="1" dirty="0">
-                <a:solidFill>
-                  <a:srgbClr val="1E2761"/>
-                </a:solidFill>
-                <a:latin typeface="Calibri" pitchFamily="34" charset="0"/>
-                <a:ea typeface="Calibri" pitchFamily="34" charset="-122"/>
-                <a:cs typeface="Calibri" pitchFamily="34" charset="-120"/>
-              </a:rPr>
-              <a:t>What Stage 3B contributes</a:t>
-            </a:r>
-            <a:endParaRPr lang="en-US" sz="1600" dirty="0"/>
-          </a:p>
-        </p:txBody>
-      </p:sp>
-      <p:sp>
-        <p:nvSpPr>
-          <p:cNvPr id="12" name="Text 10"/>
-          <p:cNvSpPr txBox="1"/>
-          <p:nvPr/>
-        </p:nvSpPr>
-        <p:spPr>
-          <a:xfrm>
-            <a:off x="8001000" y="2057400"/>
-            <a:ext cx="3657600" cy="3749040"/>
-          </a:xfrm>
-          <a:prstGeom prst="rect">
-            <a:avLst/>
-          </a:prstGeom>
-          <a:noFill/>
-          <a:ln/>
-        </p:spPr>
-        <p:txBody>
-          <a:bodyPr wrap="square" lIns="0" tIns="0" rIns="0" bIns="0" rtlCol="0" anchor="ctr"/>
-          <a:lstStyle/>
-          <a:p>
-            <a:pPr marL="342900" indent="-342900">
-              <a:lnSpc>
-                <a:spcPct val="108000"/>
-              </a:lnSpc>
-              <a:spcAft>
-                <a:spcPts val="1000"/>
-              </a:spcAft>
-              <a:buSzPct val="100000"/>
-              <a:buChar char="•"/>
-            </a:pPr>
-            <a:r>
-              <a:rPr lang="en-US" dirty="0">
-                <a:solidFill>
-                  <a:srgbClr val="222222"/>
-                </a:solidFill>
-                <a:latin typeface="Calibri" pitchFamily="34" charset="0"/>
-                <a:ea typeface="Calibri" pitchFamily="34" charset="-122"/>
-                <a:cs typeface="Calibri" pitchFamily="34" charset="-120"/>
-              </a:rPr>
-              <a:t>The combined-intervention evaluation, with exploratory assessment of the proposed mechanisms</a:t>
-            </a:r>
-            <a:endParaRPr lang="en-US" dirty="0"/>
-          </a:p>
-          <a:p>
-            <a:pPr marL="342900" indent="-342900">
-              <a:lnSpc>
-                <a:spcPct val="108000"/>
-              </a:lnSpc>
-              <a:spcAft>
-                <a:spcPts val="1000"/>
-              </a:spcAft>
-              <a:buSzPct val="100000"/>
-              <a:buChar char="•"/>
-            </a:pPr>
-            <a:r>
-              <a:rPr lang="en-US" dirty="0">
-                <a:solidFill>
-                  <a:srgbClr val="222222"/>
-                </a:solidFill>
-                <a:latin typeface="Calibri" pitchFamily="34" charset="0"/>
-                <a:ea typeface="Calibri" pitchFamily="34" charset="-122"/>
-                <a:cs typeface="Calibri" pitchFamily="34" charset="-120"/>
-              </a:rPr>
-              <a:t>§8.8 and the programme diary (Table 9.1), written to the verified classification</a:t>
-            </a:r>
-            <a:endParaRPr lang="en-US" dirty="0"/>
-          </a:p>
-          <a:p>
-            <a:pPr marL="342900" indent="-342900">
-              <a:lnSpc>
-                <a:spcPct val="108000"/>
-              </a:lnSpc>
-              <a:spcAft>
-                <a:spcPts val="1000"/>
-              </a:spcAft>
-              <a:buSzPct val="100000"/>
-              <a:buChar char="•"/>
-            </a:pPr>
-            <a:r>
-              <a:rPr lang="en-US" dirty="0">
-                <a:solidFill>
-                  <a:srgbClr val="222222"/>
-                </a:solidFill>
-                <a:latin typeface="Calibri" pitchFamily="34" charset="0"/>
-                <a:ea typeface="Calibri" pitchFamily="34" charset="-122"/>
-                <a:cs typeface="Calibri" pitchFamily="34" charset="-120"/>
-              </a:rPr>
-              <a:t>Last empirical input before the final production pass</a:t>
-            </a:r>
-            <a:endParaRPr lang="en-US" dirty="0"/>
-          </a:p>
-        </p:txBody>
-      </p:sp>
-      <p:sp>
-        <p:nvSpPr>
-          <p:cNvPr id="13" name="Text 11"/>
+              <a:t>Each stage's results licensed the next stage's question</a:t>
+            </a:r>
+          </a:p>
+        </p:txBody>
+      </p:sp>
+      <p:pic>
+        <p:nvPicPr>
+          <p:cNvPr id="4" name="Picture 3" descr="image.png"/>
+          <p:cNvPicPr>
+            <a:picLocks noChangeAspect="1"/>
+          </p:cNvPicPr>
+          <p:nvPr/>
+        </p:nvPicPr>
+        <p:blipFill>
+          <a:blip r:embed="rId3"/>
+          <a:stretch>
+            <a:fillRect/>
+          </a:stretch>
+        </p:blipFill>
+        <p:spPr>
+          <a:xfrm>
+            <a:off x="1592427" y="1298448"/>
+            <a:ext cx="9006840" cy="5088480"/>
+          </a:xfrm>
+          <a:prstGeom prst="rect">
+            <a:avLst/>
+          </a:prstGeom>
+        </p:spPr>
+      </p:pic>
+      <p:sp>
+        <p:nvSpPr>
+          <p:cNvPr id="5" name="TextBox 4"/>
           <p:cNvSpPr txBox="1"/>
           <p:nvPr/>
         </p:nvSpPr>
@@ -10372,66 +10461,22 @@
             <a:avLst/>
           </a:prstGeom>
           <a:noFill/>
-          <a:ln/>
-        </p:spPr>
-        <p:txBody>
-          <a:bodyPr wrap="square" lIns="0" tIns="0" rIns="0" bIns="0" rtlCol="0" anchor="ctr"/>
-          <a:lstStyle/>
-          <a:p>
-            <a:pPr marL="0" indent="0">
-              <a:buNone/>
-            </a:pPr>
-            <a:r>
-              <a:rPr lang="en-US" sz="1000" dirty="0">
+        </p:spPr>
+        <p:txBody>
+          <a:bodyPr wrap="square" lIns="0" rIns="0" tIns="0" bIns="0">
+            <a:spAutoFit/>
+          </a:bodyPr>
+          <a:lstStyle/>
+          <a:p>
+            <a:r>
+              <a:rPr sz="1000" b="0" i="0">
                 <a:solidFill>
                   <a:srgbClr val="5A6172"/>
                 </a:solidFill>
-                <a:latin typeface="Calibri" pitchFamily="34" charset="0"/>
-                <a:ea typeface="Calibri" pitchFamily="34" charset="-122"/>
-                <a:cs typeface="Calibri" pitchFamily="34" charset="-120"/>
-              </a:rPr>
-              <a:t>Sidney K.T. Tam  |  EngD Final Review (Update 8, rev. B)  |  PolyU ISE  |  September 2026</a:t>
-            </a:r>
-            <a:endParaRPr lang="en-US" sz="1000" dirty="0"/>
-          </a:p>
-        </p:txBody>
-      </p:sp>
-      <p:sp>
-        <p:nvSpPr>
-          <p:cNvPr id="14" name="Text 12"/>
-          <p:cNvSpPr txBox="1"/>
-          <p:nvPr/>
-        </p:nvSpPr>
-        <p:spPr>
-          <a:xfrm>
-            <a:off x="11384280" y="6473952"/>
-            <a:ext cx="365760" cy="274320"/>
-          </a:xfrm>
-          <a:prstGeom prst="rect">
-            <a:avLst/>
-          </a:prstGeom>
-          <a:noFill/>
-          <a:ln/>
-        </p:spPr>
-        <p:txBody>
-          <a:bodyPr wrap="square" lIns="0" tIns="0" rIns="0" bIns="0" rtlCol="0" anchor="ctr"/>
-          <a:lstStyle/>
-          <a:p>
-            <a:pPr marL="0" indent="0" algn="r">
-              <a:buNone/>
-            </a:pPr>
-            <a:r>
-              <a:rPr lang="en-US" sz="1000" dirty="0">
-                <a:solidFill>
-                  <a:srgbClr val="5A6172"/>
-                </a:solidFill>
-                <a:latin typeface="Calibri" pitchFamily="34" charset="0"/>
-                <a:ea typeface="Calibri" pitchFamily="34" charset="-122"/>
-                <a:cs typeface="Calibri" pitchFamily="34" charset="-120"/>
-              </a:rPr>
-              <a:t>7</a:t>
-            </a:r>
-            <a:endParaRPr lang="en-US" sz="1000" dirty="0"/>
+                <a:latin typeface="Calibri"/>
+              </a:rPr>
+              <a:t>Sidney K.T. Tam  |  EngD Final Review (Update 8, rev. D)  |  PolyU ISE  |  September 2026</a:t>
+            </a:r>
           </a:p>
         </p:txBody>
       </p:sp>
@@ -10482,7 +10527,7 @@
                 </a:solidFill>
                 <a:latin typeface="Cambria"/>
               </a:rPr>
-              <a:t>Stage 3B — first evidence from the field</a:t>
+              <a:t>Stage 3B — how it runs and where it stands</a:t>
             </a:r>
           </a:p>
         </p:txBody>
@@ -10516,14 +10561,14 @@
                 </a:solidFill>
                 <a:latin typeface="Calibri"/>
               </a:rPr>
-              <a:t>Real artifacts only; analysis awaits window close and classification</a:t>
+              <a:t>Deployment pipeline; analysis gated behind verification and the pre-specified plan</a:t>
             </a:r>
           </a:p>
         </p:txBody>
       </p:sp>
       <p:pic>
         <p:nvPicPr>
-          <p:cNvPr id="4" name="Picture 3" descr="1_consent.png"/>
+          <p:cNvPr id="4" name="Picture 3" descr="pipeline.png"/>
           <p:cNvPicPr>
             <a:picLocks noChangeAspect="1"/>
           </p:cNvPicPr>
@@ -10537,8 +10582,8 @@
         </p:blipFill>
         <p:spPr>
           <a:xfrm>
-            <a:off x="502920" y="1417320"/>
-            <a:ext cx="2697480" cy="1685925"/>
+            <a:off x="612648" y="1691640"/>
+            <a:ext cx="10972800" cy="4089009"/>
           </a:xfrm>
           <a:prstGeom prst="rect">
             <a:avLst/>
@@ -10553,8 +10598,8 @@
         </p:nvSpPr>
         <p:spPr>
           <a:xfrm>
-            <a:off x="502920" y="3200400"/>
-            <a:ext cx="2697480" cy="256032"/>
+            <a:off x="502920" y="6473952"/>
+            <a:ext cx="8229600" cy="274320"/>
           </a:xfrm>
           <a:prstGeom prst="rect">
             <a:avLst/>
@@ -10567,357 +10612,14 @@
           </a:bodyPr>
           <a:lstStyle/>
           <a:p>
-            <a:pPr algn="ctr"/>
-            <a:r>
-              <a:rPr sz="1050" b="0" i="1">
+            <a:r>
+              <a:rPr sz="1000" b="0" i="0">
                 <a:solidFill>
                   <a:srgbClr val="5A6172"/>
                 </a:solidFill>
                 <a:latin typeface="Calibri"/>
               </a:rPr>
-              <a:t>In-build consent</a:t>
-            </a:r>
-          </a:p>
-        </p:txBody>
-      </p:sp>
-      <p:pic>
-        <p:nvPicPr>
-          <p:cNvPr id="6" name="Picture 5" descr="2_gameplay.png"/>
-          <p:cNvPicPr>
-            <a:picLocks noChangeAspect="1"/>
-          </p:cNvPicPr>
-          <p:nvPr/>
-        </p:nvPicPr>
-        <p:blipFill>
-          <a:blip r:embed="rId3"/>
-          <a:stretch>
-            <a:fillRect/>
-          </a:stretch>
-        </p:blipFill>
-        <p:spPr>
-          <a:xfrm>
-            <a:off x="3346704" y="1417320"/>
-            <a:ext cx="2697480" cy="1685925"/>
-          </a:xfrm>
-          <a:prstGeom prst="rect">
-            <a:avLst/>
-          </a:prstGeom>
-        </p:spPr>
-      </p:pic>
-      <p:sp>
-        <p:nvSpPr>
-          <p:cNvPr id="7" name="TextBox 6"/>
-          <p:cNvSpPr txBox="1"/>
-          <p:nvPr/>
-        </p:nvSpPr>
-        <p:spPr>
-          <a:xfrm>
-            <a:off x="3346704" y="3200400"/>
-            <a:ext cx="2697480" cy="256032"/>
-          </a:xfrm>
-          <a:prstGeom prst="rect">
-            <a:avLst/>
-          </a:prstGeom>
-          <a:noFill/>
-        </p:spPr>
-        <p:txBody>
-          <a:bodyPr wrap="square" lIns="0" rIns="0" tIns="0" bIns="0">
-            <a:spAutoFit/>
-          </a:bodyPr>
-          <a:lstStyle/>
-          <a:p>
-            <a:pPr algn="ctr"/>
-            <a:r>
-              <a:rPr sz="1050" b="0" i="1">
-                <a:solidFill>
-                  <a:srgbClr val="5A6172"/>
-                </a:solidFill>
-                <a:latin typeface="Calibri"/>
-              </a:rPr>
-              <a:t>30-second run</a:t>
-            </a:r>
-          </a:p>
-        </p:txBody>
-      </p:sp>
-      <p:pic>
-        <p:nvPicPr>
-          <p:cNvPr id="8" name="Picture 7" descr="3_questionnaire.png"/>
-          <p:cNvPicPr>
-            <a:picLocks noChangeAspect="1"/>
-          </p:cNvPicPr>
-          <p:nvPr/>
-        </p:nvPicPr>
-        <p:blipFill>
-          <a:blip r:embed="rId4"/>
-          <a:stretch>
-            <a:fillRect/>
-          </a:stretch>
-        </p:blipFill>
-        <p:spPr>
-          <a:xfrm>
-            <a:off x="6190488" y="1417320"/>
-            <a:ext cx="2697480" cy="1685925"/>
-          </a:xfrm>
-          <a:prstGeom prst="rect">
-            <a:avLst/>
-          </a:prstGeom>
-        </p:spPr>
-      </p:pic>
-      <p:sp>
-        <p:nvSpPr>
-          <p:cNvPr id="9" name="TextBox 8"/>
-          <p:cNvSpPr txBox="1"/>
-          <p:nvPr/>
-        </p:nvSpPr>
-        <p:spPr>
-          <a:xfrm>
-            <a:off x="6190488" y="3200400"/>
-            <a:ext cx="2697480" cy="256032"/>
-          </a:xfrm>
-          <a:prstGeom prst="rect">
-            <a:avLst/>
-          </a:prstGeom>
-          <a:noFill/>
-        </p:spPr>
-        <p:txBody>
-          <a:bodyPr wrap="square" lIns="0" rIns="0" tIns="0" bIns="0">
-            <a:spAutoFit/>
-          </a:bodyPr>
-          <a:lstStyle/>
-          <a:p>
-            <a:pPr algn="ctr"/>
-            <a:r>
-              <a:rPr sz="1050" b="0" i="1">
-                <a:solidFill>
-                  <a:srgbClr val="5A6172"/>
-                </a:solidFill>
-                <a:latin typeface="Calibri"/>
-              </a:rPr>
-              <a:t>End-screen questionnaire</a:t>
-            </a:r>
-          </a:p>
-        </p:txBody>
-      </p:sp>
-      <p:pic>
-        <p:nvPicPr>
-          <p:cNvPr id="10" name="Picture 9" descr="4_return_screen.png"/>
-          <p:cNvPicPr>
-            <a:picLocks noChangeAspect="1"/>
-          </p:cNvPicPr>
-          <p:nvPr/>
-        </p:nvPicPr>
-        <p:blipFill>
-          <a:blip r:embed="rId5"/>
-          <a:stretch>
-            <a:fillRect/>
-          </a:stretch>
-        </p:blipFill>
-        <p:spPr>
-          <a:xfrm>
-            <a:off x="9034272" y="1417320"/>
-            <a:ext cx="2697480" cy="1685925"/>
-          </a:xfrm>
-          <a:prstGeom prst="rect">
-            <a:avLst/>
-          </a:prstGeom>
-        </p:spPr>
-      </p:pic>
-      <p:sp>
-        <p:nvSpPr>
-          <p:cNvPr id="11" name="TextBox 10"/>
-          <p:cNvSpPr txBox="1"/>
-          <p:nvPr/>
-        </p:nvSpPr>
-        <p:spPr>
-          <a:xfrm>
-            <a:off x="9034272" y="3200400"/>
-            <a:ext cx="2697480" cy="256032"/>
-          </a:xfrm>
-          <a:prstGeom prst="rect">
-            <a:avLst/>
-          </a:prstGeom>
-          <a:noFill/>
-        </p:spPr>
-        <p:txBody>
-          <a:bodyPr wrap="square" lIns="0" rIns="0" tIns="0" bIns="0">
-            <a:spAutoFit/>
-          </a:bodyPr>
-          <a:lstStyle/>
-          <a:p>
-            <a:pPr algn="ctr"/>
-            <a:r>
-              <a:rPr sz="1050" b="0" i="1">
-                <a:solidFill>
-                  <a:srgbClr val="5A6172"/>
-                </a:solidFill>
-                <a:latin typeface="Calibri"/>
-              </a:rPr>
-              <a:t>Results return</a:t>
-            </a:r>
-          </a:p>
-        </p:txBody>
-      </p:sp>
-      <p:sp>
-        <p:nvSpPr>
-          <p:cNvPr id="12" name="Rounded Rectangle 11"/>
-          <p:cNvSpPr/>
-          <p:nvPr/>
-        </p:nvSpPr>
-        <p:spPr>
-          <a:xfrm>
-            <a:off x="502920" y="3611880"/>
-            <a:ext cx="11192256" cy="1600200"/>
-          </a:xfrm>
-          <a:prstGeom prst="roundRect">
-            <a:avLst/>
-          </a:prstGeom>
-          <a:solidFill>
-            <a:srgbClr val="EAF3EE"/>
-          </a:solidFill>
-          <a:ln>
-            <a:noFill/>
-          </a:ln>
-        </p:spPr>
-        <p:style>
-          <a:lnRef idx="1">
-            <a:schemeClr val="accent1"/>
-          </a:lnRef>
-          <a:fillRef idx="3">
-            <a:schemeClr val="accent1"/>
-          </a:fillRef>
-          <a:effectRef idx="2">
-            <a:schemeClr val="accent1"/>
-          </a:effectRef>
-          <a:fontRef idx="minor">
-            <a:schemeClr val="lt1"/>
-          </a:fontRef>
-        </p:style>
-        <p:txBody>
-          <a:bodyPr rtlCol="0" anchor="ctr" wrap="square" lIns="274320" rIns="274320" tIns="109728"/>
-          <a:lstStyle/>
-          <a:p>
-            <a:pPr algn="ctr"/>
-            <a:r>
-              <a:rPr sz="1400" b="1">
-                <a:solidFill>
-                  <a:srgbClr val="2C6E49"/>
-                </a:solidFill>
-                <a:latin typeface="Calibri"/>
-              </a:rPr>
-              <a:t>First verified return — complete chain of custody</a:t>
-            </a:r>
-          </a:p>
-          <a:p>
-            <a:r>
-              <a:rPr sz="1200">
-                <a:solidFill>
-                  <a:srgbClr val="222222"/>
-                </a:solidFill>
-                <a:latin typeface="Calibri"/>
-              </a:rPr>
-              <a:t>Game file (device copy DEV2) sent to a distributor by WeChat 10 Aug → participant consented and played 15 Aug (in-build timestamp) → return e-mailed to the researcher the same day → archived as received. Return fields match the deployed build generation exactly (arm, failure-mode, scoring). Enrolment 45–64/F; one session; questionnaire complete.</a:t>
-            </a:r>
-          </a:p>
-        </p:txBody>
-      </p:sp>
-      <p:sp>
-        <p:nvSpPr>
-          <p:cNvPr id="13" name="TextBox 12"/>
-          <p:cNvSpPr txBox="1"/>
-          <p:nvPr/>
-        </p:nvSpPr>
-        <p:spPr>
-          <a:xfrm>
-            <a:off x="502920" y="5394960"/>
-            <a:ext cx="11192256" cy="868680"/>
-          </a:xfrm>
-          <a:prstGeom prst="rect">
-            <a:avLst/>
-          </a:prstGeom>
-          <a:noFill/>
-        </p:spPr>
-        <p:txBody>
-          <a:bodyPr wrap="square" lIns="0" rIns="0" tIns="0" bIns="0">
-            <a:spAutoFit/>
-          </a:bodyPr>
-          <a:lstStyle/>
-          <a:p>
-            <a:r>
-              <a:rPr sz="1250" b="0" i="0">
-                <a:solidFill>
-                  <a:srgbClr val="222222"/>
-                </a:solidFill>
-                <a:latin typeface="Calibri"/>
-              </a:rPr>
-              <a:t>Deployment status (author records): ~20 distributors reached ~100 recipients; distribution from 9–12 Aug onward, after the analysis plan was fixed in the repository (9 Aug). Returns are being collected via each device's built-in archive; the count will be reported at window close.</a:t>
-            </a:r>
-          </a:p>
-        </p:txBody>
-      </p:sp>
-      <p:sp>
-        <p:nvSpPr>
-          <p:cNvPr id="14" name="TextBox 13"/>
-          <p:cNvSpPr txBox="1"/>
-          <p:nvPr/>
-        </p:nvSpPr>
-        <p:spPr>
-          <a:xfrm>
-            <a:off x="502920" y="6473952"/>
-            <a:ext cx="8229600" cy="274320"/>
-          </a:xfrm>
-          <a:prstGeom prst="rect">
-            <a:avLst/>
-          </a:prstGeom>
-          <a:noFill/>
-        </p:spPr>
-        <p:txBody>
-          <a:bodyPr wrap="square" lIns="0" rIns="0" tIns="0" bIns="0">
-            <a:spAutoFit/>
-          </a:bodyPr>
-          <a:lstStyle/>
-          <a:p>
-            <a:r>
-              <a:rPr sz="1000" b="0" i="0">
-                <a:solidFill>
-                  <a:srgbClr val="5A6172"/>
-                </a:solidFill>
-                <a:latin typeface="Calibri"/>
-              </a:rPr>
               <a:t>Sidney K.T. Tam  |  EngD Final Review (Update 8, rev. D)  |  PolyU ISE  |  September 2026</a:t>
-            </a:r>
-          </a:p>
-        </p:txBody>
-      </p:sp>
-      <p:sp>
-        <p:nvSpPr>
-          <p:cNvPr id="15" name="TextBox 14"/>
-          <p:cNvSpPr txBox="1"/>
-          <p:nvPr/>
-        </p:nvSpPr>
-        <p:spPr>
-          <a:xfrm>
-            <a:off x="11384280" y="6473952"/>
-            <a:ext cx="365760" cy="274320"/>
-          </a:xfrm>
-          <a:prstGeom prst="rect">
-            <a:avLst/>
-          </a:prstGeom>
-          <a:noFill/>
-        </p:spPr>
-        <p:txBody>
-          <a:bodyPr wrap="square" lIns="0" rIns="0" tIns="0" bIns="0">
-            <a:spAutoFit/>
-          </a:bodyPr>
-          <a:lstStyle/>
-          <a:p>
-            <a:r>
-              <a:rPr sz="1000" b="0" i="0">
-                <a:solidFill>
-                  <a:srgbClr val="5A6172"/>
-                </a:solidFill>
-                <a:latin typeface="Calibri"/>
-              </a:rPr>
-              <a:t>9</a:t>
             </a:r>
           </a:p>
         </p:txBody>

</xml_diff>

<commit_message>
Speaker notes: document the deployed 2x2 (arm x failure-mode) and its confirmatory-vs-exploratory split
Co-Authored-By: Claude Fable 5 <noreply@anthropic.com>
Claude-Session: https://claude.ai/code/session_01KoT3i8geZspYBMMKVYJUTG
</commit_message>
<xml_diff>
--- a/docs/presentations/EngD_Update_8_Final_Review_September2026_revD.pptx
+++ b/docs/presentations/EngD_Update_8_Final_Review_September2026_revD.pptx
@@ -832,7 +832,7 @@
           <a:lstStyle/>
           <a:p>
             <a:r>
-              <a:t>45 sec. Five steps, one gate: the plan was fixed before distribution; play is consented in-build and silently randomised; returns come back through each device's archive; verification and classification come before any analysis. Status: window open, close date to be set with my supervisor, everything inside the ethics period to 30 October. Deployment records are archived: distribution messages, the deployed device files, and the first verified return with a complete dated chain.</a:t>
+              <a:t>45 sec. Five steps, one gate: the plan was fixed before distribution; play is consented in-build and silently randomised; returns come back through each device's archive; verification and classification come before any analysis. Status: window open, close date to be set with my supervisor, everything inside the ethics period to 30 October. Deployment records are archived: distribution messages, the deployed device files, and the first verified return with a complete dated chain. If asked about the assignment detail: it is a silent 2x2 inside one game file - adaptive vs static support, crossed with a failure-mode factor (zero-fail vs game-over-possible), which operationalises the failure trigger inside 3B. The confirmatory contrast is the adaptive-vs-static main effect pooled across failure modes; the failure-mode effect and interaction are pre-specified as exploratory because cell sizes will be small. Do not call the failure-mode factor 'coupling' - no clinical verdict exists in either mode.</a:t>
             </a:r>
           </a:p>
         </p:txBody>
@@ -1337,7 +1337,7 @@
           <a:lstStyle/>
           <a:p>
             <a:r>
-              <a:t>60 sec. Walk the diagram left to right: coupled deployment - use collapsed; decoupled deployment - participation held; the 3A result licensed the question 3B answers - can measurement stay visible if the system adapts to the player? Designed August 2026, after the 3A results; pre-specified before its own recruitment (repository-dated 8-9 Aug). H-3B is exploratory: combined effect only, no component isolation. Per-protocol participant experience if asked: bilingual v3.0 game, in-build consent, silent random assignment (adaptive calibration + trajectory + coaching vs static), end-screen questionnaire, one-file export, target N &gt;= 40. If challenged on sequence: retrospectively motivated, prospectively specified - the intended logic of a staged programme.</a:t>
+              <a:t>60 sec. Walk the diagram left to right: coupled deployment - use collapsed; decoupled deployment - participation held; the 3A result licensed the question 3B answers - can measurement stay visible if the system adapts to the player? Designed August 2026, after the 3A results; pre-specified before its own recruitment (repository-dated 8-9 Aug). H-3B is exploratory: combined effect only, no component isolation. Per-protocol participant experience if asked: bilingual v3.0 game, in-build consent, silent random assignment (adaptive calibration + trajectory + coaching vs static), end-screen questionnaire, one-file export, target N &gt;= 40. If challenged on sequence: retrospectively motivated, prospectively specified - the intended logic of a staged programme. If asked about the assignment detail: it is a silent 2x2 inside one game file - adaptive vs static support, crossed with a failure-mode factor (zero-fail vs game-over-possible), which operationalises the failure trigger inside 3B. The confirmatory contrast is the adaptive-vs-static main effect pooled across failure modes; the failure-mode effect and interaction are pre-specified as exploratory because cell sizes will be small. Do not call the failure-mode factor 'coupling' - no clinical verdict exists in either mode.</a:t>
             </a:r>
           </a:p>
         </p:txBody>

</xml_diff>